<commit_message>
docs: complete contest submission metadata and skill
Signed-off-by: wx719 <3474311506@qq.com>
</commit_message>
<xml_diff>
--- a/submission/VelaPoka_project_introduction.pptx
+++ b/submission/VelaPoka_project_introduction.pptx
@@ -72,7 +72,7 @@
         <p:txBody>
           <a:bodyPr/>
           <a:p>
-            <a:fld id="{5824F09E-F445-4422-8393-FD1897C7B7F3}" type="slidenum">
+            <a:fld id="{2E47FD72-AB48-42C5-88EB-AE9BE77F9545}" type="slidenum">
               <a:t>&lt;#&gt;</a:t>
             </a:fld>
           </a:p>
@@ -260,7 +260,7 @@
         <p:txBody>
           <a:bodyPr/>
           <a:p>
-            <a:fld id="{06BBAB76-D31D-4A60-876C-001A189BE301}" type="slidenum">
+            <a:fld id="{B220CD28-BDC0-4A99-ABDB-E3AF33D6C20F}" type="slidenum">
               <a:t>&lt;#&gt;</a:t>
             </a:fld>
           </a:p>
@@ -516,7 +516,7 @@
         <p:txBody>
           <a:bodyPr/>
           <a:p>
-            <a:fld id="{4C5F56B1-CE22-485C-8853-93C339F753A1}" type="slidenum">
+            <a:fld id="{4E9C3099-DD5F-46CA-889D-10C376503C31}" type="slidenum">
               <a:t>&lt;#&gt;</a:t>
             </a:fld>
           </a:p>
@@ -840,7 +840,7 @@
         <p:txBody>
           <a:bodyPr/>
           <a:p>
-            <a:fld id="{18C956B2-F5D2-4DF3-B0CB-81599A278944}" type="slidenum">
+            <a:fld id="{E6B62B23-9F93-447C-B381-CEB7CE1A806A}" type="slidenum">
               <a:t>&lt;#&gt;</a:t>
             </a:fld>
           </a:p>
@@ -997,7 +997,7 @@
         <p:txBody>
           <a:bodyPr/>
           <a:p>
-            <a:fld id="{08CC9BFE-28A2-495D-A042-CCB5AE3734E4}" type="slidenum">
+            <a:fld id="{FBC6E95A-A3B0-497A-9298-CEBC5E4F1C77}" type="slidenum">
               <a:t>&lt;#&gt;</a:t>
             </a:fld>
           </a:p>
@@ -1151,7 +1151,7 @@
         <p:txBody>
           <a:bodyPr/>
           <a:p>
-            <a:fld id="{FB06469F-549A-4115-B4CB-62072FFBEC2A}" type="slidenum">
+            <a:fld id="{51D1BB7F-5507-4645-970D-3EDB198FBB9E}" type="slidenum">
               <a:t>&lt;#&gt;</a:t>
             </a:fld>
           </a:p>
@@ -1339,7 +1339,7 @@
         <p:txBody>
           <a:bodyPr/>
           <a:p>
-            <a:fld id="{6E2003FC-BF6B-4657-8EF5-13A731D00980}" type="slidenum">
+            <a:fld id="{C6543F97-252F-49E7-AED4-BFF5D93C352A}" type="slidenum">
               <a:t>&lt;#&gt;</a:t>
             </a:fld>
           </a:p>
@@ -1459,7 +1459,7 @@
         <p:txBody>
           <a:bodyPr/>
           <a:p>
-            <a:fld id="{6A848AE2-A529-4B6C-807E-E394589068AD}" type="slidenum">
+            <a:fld id="{B739E658-82F8-4D92-98E0-F49368900642}" type="slidenum">
               <a:t>&lt;#&gt;</a:t>
             </a:fld>
           </a:p>
@@ -1579,7 +1579,7 @@
         <p:txBody>
           <a:bodyPr/>
           <a:p>
-            <a:fld id="{F8E98C4D-9603-42C3-B5DF-2A7ABC99EAF5}" type="slidenum">
+            <a:fld id="{80323A29-4314-431D-A477-FCCDE5B74738}" type="slidenum">
               <a:t>&lt;#&gt;</a:t>
             </a:fld>
           </a:p>
@@ -1801,7 +1801,7 @@
         <p:txBody>
           <a:bodyPr/>
           <a:p>
-            <a:fld id="{DE7338A8-30DF-4176-AFCB-F8846E180D8B}" type="slidenum">
+            <a:fld id="{BB438D73-C97E-42C1-883F-FD6718FDF392}" type="slidenum">
               <a:t>&lt;#&gt;</a:t>
             </a:fld>
           </a:p>
@@ -2023,7 +2023,7 @@
         <p:txBody>
           <a:bodyPr/>
           <a:p>
-            <a:fld id="{DB5419F1-717F-454C-BC24-FEA80262D16B}" type="slidenum">
+            <a:fld id="{C8A86259-3117-4BE1-9A56-633A0D3822CE}" type="slidenum">
               <a:t>&lt;#&gt;</a:t>
             </a:fld>
           </a:p>
@@ -2245,7 +2245,7 @@
         <p:txBody>
           <a:bodyPr/>
           <a:p>
-            <a:fld id="{0CF6CEF5-D89B-4BAC-95AA-289F396B7799}" type="slidenum">
+            <a:fld id="{EE7C3851-09C1-4BEB-8F84-2C59C868399A}" type="slidenum">
               <a:t>&lt;#&gt;</a:t>
             </a:fld>
           </a:p>
@@ -2657,7 +2657,7 @@
             <a:pPr algn="r">
               <a:buNone/>
             </a:pPr>
-            <a:fld id="{C752B270-EE2F-4F50-AC02-B04F1CBD7794}" type="slidenum">
+            <a:fld id="{86FF40E2-4C99-4D3F-A1EC-5F75FA7B3051}" type="slidenum">
               <a:rPr b="0" lang="en-US" sz="1400" spc="-1" strike="noStrike">
                 <a:latin typeface="Times New Roman"/>
               </a:rPr>
@@ -3312,8 +3312,8 @@
         </p:nvSpPr>
         <p:spPr>
           <a:xfrm>
-            <a:off x="558000" y="6210000"/>
-            <a:ext cx="5400000" cy="234000"/>
+            <a:off x="558000" y="5922000"/>
+            <a:ext cx="7020000" cy="594000"/>
           </a:xfrm>
           <a:prstGeom prst="rect">
             <a:avLst/>
@@ -3329,24 +3329,150 @@
           </a:bodyPr>
           <a:p>
             <a:r>
-              <a:rPr b="0" lang="zh-CN" sz="1200" spc="-1" strike="noStrike">
-                <a:solidFill>
-                  <a:srgbClr val="afc3d5"/>
-                </a:solidFill>
-                <a:latin typeface="Noto Sans CJK SC"/>
-              </a:rPr>
-              <a:t>参赛者：</a:t>
-            </a:r>
-            <a:r>
-              <a:rPr b="0" lang="en-US" sz="1200" spc="-1" strike="noStrike">
-                <a:solidFill>
-                  <a:srgbClr val="afc3d5"/>
-                </a:solidFill>
-                <a:latin typeface="Noto Sans CJK SC"/>
-              </a:rPr>
-              <a:t>wx719   ·   2026.09</a:t>
-            </a:r>
-            <a:endParaRPr b="0" lang="en-US" sz="1200" spc="-1" strike="noStrike">
+              <a:rPr b="0" lang="zh-CN" sz="1100" spc="-1" strike="noStrike">
+                <a:solidFill>
+                  <a:srgbClr val="afc3d5"/>
+                </a:solidFill>
+                <a:latin typeface="Noto Sans CJK SC"/>
+              </a:rPr>
+              <a:t>队伍：赚钱买板子  </a:t>
+            </a:r>
+            <a:r>
+              <a:rPr b="0" lang="en-US" sz="1100" spc="-1" strike="noStrike">
+                <a:solidFill>
+                  <a:srgbClr val="afc3d5"/>
+                </a:solidFill>
+                <a:latin typeface="Noto Sans CJK SC"/>
+              </a:rPr>
+              <a:t>·  </a:t>
+            </a:r>
+            <a:r>
+              <a:rPr b="0" lang="zh-CN" sz="1100" spc="-1" strike="noStrike">
+                <a:solidFill>
+                  <a:srgbClr val="afc3d5"/>
+                </a:solidFill>
+                <a:latin typeface="Noto Sans CJK SC"/>
+              </a:rPr>
+              <a:t>编号：</a:t>
+            </a:r>
+            <a:r>
+              <a:rPr b="0" lang="en-US" sz="1100" spc="-1" strike="noStrike">
+                <a:solidFill>
+                  <a:srgbClr val="afc3d5"/>
+                </a:solidFill>
+                <a:latin typeface="Noto Sans CJK SC"/>
+              </a:rPr>
+              <a:t>284  ·  </a:t>
+            </a:r>
+            <a:r>
+              <a:rPr b="0" lang="zh-CN" sz="1100" spc="-1" strike="noStrike">
+                <a:solidFill>
+                  <a:srgbClr val="afc3d5"/>
+                </a:solidFill>
+                <a:latin typeface="Noto Sans CJK SC"/>
+              </a:rPr>
+              <a:t>成员：</a:t>
+            </a:r>
+            <a:r>
+              <a:rPr b="0" lang="en-US" sz="1100" spc="-1" strike="noStrike">
+                <a:solidFill>
+                  <a:srgbClr val="afc3d5"/>
+                </a:solidFill>
+                <a:latin typeface="Noto Sans CJK SC"/>
+              </a:rPr>
+              <a:t>wx719</a:t>
+            </a:r>
+            <a:endParaRPr b="0" lang="en-US" sz="1100" spc="-1" strike="noStrike">
+              <a:solidFill>
+                <a:srgbClr val="afc3d5"/>
+              </a:solidFill>
+              <a:latin typeface="Noto Sans CJK SC"/>
+              <a:ea typeface="Noto Sans CJK SC"/>
+            </a:endParaRPr>
+          </a:p>
+          <a:p>
+            <a:r>
+              <a:rPr b="0" lang="zh-CN" sz="1100" spc="-1" strike="noStrike">
+                <a:solidFill>
+                  <a:srgbClr val="afc3d5"/>
+                </a:solidFill>
+                <a:latin typeface="Noto Sans CJK SC"/>
+              </a:rPr>
+              <a:t>分工：</a:t>
+            </a:r>
+            <a:r>
+              <a:rPr b="0" lang="en-US" sz="1100" spc="-1" strike="noStrike">
+                <a:solidFill>
+                  <a:srgbClr val="afc3d5"/>
+                </a:solidFill>
+                <a:latin typeface="Noto Sans CJK SC"/>
+              </a:rPr>
+              <a:t>ESP32-P4 BSP / </a:t>
+            </a:r>
+            <a:r>
+              <a:rPr b="0" lang="zh-CN" sz="1100" spc="-1" strike="noStrike">
+                <a:solidFill>
+                  <a:srgbClr val="afc3d5"/>
+                </a:solidFill>
+                <a:latin typeface="Noto Sans CJK SC"/>
+              </a:rPr>
+              <a:t>视觉应用 </a:t>
+            </a:r>
+            <a:r>
+              <a:rPr b="0" lang="en-US" sz="1100" spc="-1" strike="noStrike">
+                <a:solidFill>
+                  <a:srgbClr val="afc3d5"/>
+                </a:solidFill>
+                <a:latin typeface="Noto Sans CJK SC"/>
+              </a:rPr>
+              <a:t>/ </a:t>
+            </a:r>
+            <a:r>
+              <a:rPr b="0" lang="zh-CN" sz="1100" spc="-1" strike="noStrike">
+                <a:solidFill>
+                  <a:srgbClr val="afc3d5"/>
+                </a:solidFill>
+                <a:latin typeface="Noto Sans CJK SC"/>
+              </a:rPr>
+              <a:t>实板调试 </a:t>
+            </a:r>
+            <a:r>
+              <a:rPr b="0" lang="en-US" sz="1100" spc="-1" strike="noStrike">
+                <a:solidFill>
+                  <a:srgbClr val="afc3d5"/>
+                </a:solidFill>
+                <a:latin typeface="Noto Sans CJK SC"/>
+              </a:rPr>
+              <a:t>/ </a:t>
+            </a:r>
+            <a:r>
+              <a:rPr b="0" lang="zh-CN" sz="1100" spc="-1" strike="noStrike">
+                <a:solidFill>
+                  <a:srgbClr val="afc3d5"/>
+                </a:solidFill>
+                <a:latin typeface="Noto Sans CJK SC"/>
+              </a:rPr>
+              <a:t>测试文档</a:t>
+            </a:r>
+            <a:endParaRPr b="0" lang="en-US" sz="1100" spc="-1" strike="noStrike">
+              <a:solidFill>
+                <a:srgbClr val="afc3d5"/>
+              </a:solidFill>
+              <a:latin typeface="Noto Sans CJK SC"/>
+              <a:ea typeface="Noto Sans CJK SC"/>
+            </a:endParaRPr>
+          </a:p>
+          <a:p>
+            <a:r>
+              <a:rPr b="0" lang="zh-CN" sz="1100" spc="-1" strike="noStrike">
+                <a:solidFill>
+                  <a:srgbClr val="afc3d5"/>
+                </a:solidFill>
+                <a:latin typeface="Noto Sans CJK SC"/>
+              </a:rPr>
+              <a:t>选题方向：端侧视觉与嵌入式系统</a:t>
+            </a:r>
+            <a:endParaRPr b="0" lang="en-US" sz="1100" spc="-1" strike="noStrike">
               <a:solidFill>
                 <a:srgbClr val="afc3d5"/>
               </a:solidFill>

</xml_diff>